<commit_message>
Fix PPTX schema errors: element order and phantom slideMaster refs
</commit_message>
<xml_diff>
--- a/Loop_D_Loops_Workflow_Presentation.pptx
+++ b/Loop_D_Loops_Workflow_Presentation.pptx
@@ -4,6 +4,9 @@
   <p:sldMasterIdLst>
     <p:sldMasterId id="2147483648" r:id="rId1"/>
   </p:sldMasterIdLst>
+  <p:notesMasterIdLst>
+    <p:notesMasterId r:id="rId12"/>
+  </p:notesMasterIdLst>
   <p:sldIdLst>
     <p:sldId id="256" r:id="rId2"/>
     <p:sldId id="257" r:id="rId3"/>
@@ -16,9 +19,6 @@
     <p:sldId id="264" r:id="rId10"/>
     <p:sldId id="265" r:id="rId11"/>
   </p:sldIdLst>
-  <p:notesMasterIdLst>
-    <p:notesMasterId r:id="rId12"/>
-  </p:notesMasterIdLst>
   <p:sldSz cx="18288000" cy="10287000"/>
   <p:notesSz cx="10287000" cy="18288000"/>
   <p:defaultTextStyle>
@@ -2024,7 +2024,7 @@
                 <a:ea typeface="Arial" pitchFamily="34" charset="-122"/>
                 <a:cs typeface="Arial" pitchFamily="34" charset="-120"/>
               </a:rPr>
-              <a:t>  /  10</a:t>
+              <a:t xml:space="preserve">  /  10</a:t>
             </a:r>
             <a:endParaRPr lang="en-US" sz="1300" dirty="0"/>
           </a:p>
@@ -4727,7 +4727,7 @@
                 <a:ea typeface="Arial" pitchFamily="34" charset="-122"/>
                 <a:cs typeface="Arial" pitchFamily="34" charset="-120"/>
               </a:rPr>
-              <a:t> LOOPS</a:t>
+              <a:t xml:space="preserve"> LOOPS</a:t>
             </a:r>
             <a:endParaRPr lang="en-US" sz="11800" dirty="0"/>
           </a:p>
@@ -4766,7 +4766,7 @@
                 <a:ea typeface="Arial" pitchFamily="34" charset="-122"/>
                 <a:cs typeface="Arial" pitchFamily="34" charset="-120"/>
               </a:rPr>
-              <a:t>because loops is so </a:t>
+              <a:t xml:space="preserve">because loops is so </a:t>
             </a:r>
             <a:pPr algn="ctr" indent="0" marL="0">
               <a:buNone/>
@@ -4872,7 +4872,7 @@
                 <a:ea typeface="Arial" pitchFamily="34" charset="-122"/>
                 <a:cs typeface="Arial" pitchFamily="34" charset="-120"/>
               </a:rPr>
-              <a:t>  ·  </a:t>
+              <a:t xml:space="preserve">  ·  </a:t>
             </a:r>
             <a:pPr algn="ctr" indent="0" marL="0">
               <a:buNone/>
@@ -4900,7 +4900,7 @@
                 <a:ea typeface="Arial" pitchFamily="34" charset="-122"/>
                 <a:cs typeface="Arial" pitchFamily="34" charset="-120"/>
               </a:rPr>
-              <a:t>  ·  </a:t>
+              <a:t xml:space="preserve">  ·  </a:t>
             </a:r>
             <a:pPr algn="ctr" indent="0" marL="0">
               <a:buNone/>
@@ -5300,7 +5300,7 @@
                 <a:ea typeface="Arial" pitchFamily="34" charset="-122"/>
                 <a:cs typeface="Arial" pitchFamily="34" charset="-120"/>
               </a:rPr>
-              <a:t>  /  10</a:t>
+              <a:t xml:space="preserve">  /  10</a:t>
             </a:r>
             <a:endParaRPr lang="en-US" sz="1300" dirty="0"/>
           </a:p>
@@ -8318,7 +8318,7 @@
                 <a:ea typeface="Arial" pitchFamily="34" charset="-122"/>
                 <a:cs typeface="Arial" pitchFamily="34" charset="-120"/>
               </a:rPr>
-              <a:t>IT'S </a:t>
+              <a:t xml:space="preserve">IT'S </a:t>
             </a:r>
             <a:pPr algn="ctr" indent="0" marL="0">
               <a:buNone/>
@@ -8852,7 +8852,7 @@
                 <a:ea typeface="Arial" pitchFamily="34" charset="-122"/>
                 <a:cs typeface="Arial" pitchFamily="34" charset="-120"/>
               </a:rPr>
-              <a:t>  /  10</a:t>
+              <a:t xml:space="preserve">  /  10</a:t>
             </a:r>
             <a:endParaRPr lang="en-US" sz="1300" dirty="0"/>
           </a:p>
@@ -11581,7 +11581,7 @@
                 <a:ea typeface="Arial" pitchFamily="34" charset="-122"/>
                 <a:cs typeface="Arial" pitchFamily="34" charset="-120"/>
               </a:rPr>
-              <a:t>  /  10</a:t>
+              <a:t xml:space="preserve">  /  10</a:t>
             </a:r>
             <a:endParaRPr lang="en-US" sz="1300" dirty="0"/>
           </a:p>
@@ -14448,7 +14448,7 @@
                 <a:ea typeface="Arial" pitchFamily="34" charset="-122"/>
                 <a:cs typeface="Arial" pitchFamily="34" charset="-120"/>
               </a:rPr>
-              <a:t>  /  10</a:t>
+              <a:t xml:space="preserve">  /  10</a:t>
             </a:r>
             <a:endParaRPr lang="en-US" sz="1300" dirty="0"/>
           </a:p>
@@ -17596,7 +17596,7 @@
                 <a:ea typeface="Arial" pitchFamily="34" charset="-122"/>
                 <a:cs typeface="Arial" pitchFamily="34" charset="-120"/>
               </a:rPr>
-              <a:t>  /  10</a:t>
+              <a:t xml:space="preserve">  /  10</a:t>
             </a:r>
             <a:endParaRPr lang="en-US" sz="1300" dirty="0"/>
           </a:p>
@@ -20086,7 +20086,7 @@
                 <a:ea typeface="Arial" pitchFamily="34" charset="-122"/>
                 <a:cs typeface="Arial" pitchFamily="34" charset="-120"/>
               </a:rPr>
-              <a:t>  /  10</a:t>
+              <a:t xml:space="preserve">  /  10</a:t>
             </a:r>
             <a:endParaRPr lang="en-US" sz="1300" dirty="0"/>
           </a:p>
@@ -22276,7 +22276,7 @@
                 <a:ea typeface="Arial" pitchFamily="34" charset="-122"/>
                 <a:cs typeface="Arial" pitchFamily="34" charset="-120"/>
               </a:rPr>
-              <a:t>  /  10</a:t>
+              <a:t xml:space="preserve">  /  10</a:t>
             </a:r>
             <a:endParaRPr lang="en-US" sz="1300" dirty="0"/>
           </a:p>
@@ -25344,7 +25344,7 @@
                 <a:ea typeface="Arial" pitchFamily="34" charset="-122"/>
                 <a:cs typeface="Arial" pitchFamily="34" charset="-120"/>
               </a:rPr>
-              <a:t>  /  10</a:t>
+              <a:t xml:space="preserve">  /  10</a:t>
             </a:r>
             <a:endParaRPr lang="en-US" sz="1300" dirty="0"/>
           </a:p>
@@ -26786,7 +26786,7 @@
                 <a:ea typeface="Consolas" pitchFamily="34" charset="-122"/>
                 <a:cs typeface="Consolas" pitchFamily="34" charset="-120"/>
               </a:rPr>
-              <a:t>Always end your final output with:  </a:t>
+              <a:t xml:space="preserve">Always end your final output with:  </a:t>
             </a:r>
             <a:endParaRPr lang="en-US" sz="1500" dirty="0"/>
           </a:p>
@@ -27212,7 +27212,7 @@
                 <a:ea typeface="Arial" pitchFamily="34" charset="-122"/>
                 <a:cs typeface="Arial" pitchFamily="34" charset="-120"/>
               </a:rPr>
-              <a:t>  /  10</a:t>
+              <a:t xml:space="preserve">  /  10</a:t>
             </a:r>
             <a:endParaRPr lang="en-US" sz="1300" dirty="0"/>
           </a:p>

</xml_diff>